<commit_message>
Enhance presentation generation script with auto-install for dependencies and improved slide content
</commit_message>
<xml_diff>
--- a/docs/presentation/Agentic_AI_Code_Review_Demo.pptx
+++ b/docs/presentation/Agentic_AI_Code_Review_Demo.pptx
@@ -3114,7 +3114,7 @@
         <p:spPr>
           <a:xfrm>
             <a:off x="0" y="0"/>
-            <a:ext cx="12188952" cy="1097280"/>
+            <a:ext cx="12191695" cy="1280160"/>
           </a:xfrm>
           <a:prstGeom prst="rect">
             <a:avLst/>
@@ -3156,8 +3156,8 @@
         </p:nvSpPr>
         <p:spPr>
           <a:xfrm>
-            <a:off x="640080" y="1463040"/>
-            <a:ext cx="10972800" cy="1097280"/>
+            <a:off x="548640" y="1417320"/>
+            <a:ext cx="10972800" cy="868680"/>
           </a:xfrm>
           <a:prstGeom prst="rect">
             <a:avLst/>
@@ -3170,15 +3170,13 @@
           </a:bodyPr>
           <a:lstStyle/>
           <a:p>
-            <a:pPr>
-              <a:defRPr sz="3000" b="1">
+            <a:r>
+              <a:rPr sz="3000" b="1">
                 <a:solidFill>
                   <a:srgbClr val="0E2C54"/>
                 </a:solidFill>
                 <a:latin typeface="Aptos"/>
-              </a:defRPr>
-            </a:pPr>
-            <a:r>
+              </a:rPr>
               <a:t>Agentic AI for Android PR Reviews</a:t>
             </a:r>
           </a:p>
@@ -3192,8 +3190,8 @@
         </p:nvSpPr>
         <p:spPr>
           <a:xfrm>
-            <a:off x="658368" y="2331720"/>
-            <a:ext cx="9875520" cy="914400"/>
+            <a:off x="566928" y="2331720"/>
+            <a:ext cx="10058400" cy="640080"/>
           </a:xfrm>
           <a:prstGeom prst="rect">
             <a:avLst/>
@@ -3207,7 +3205,7 @@
           <a:lstStyle/>
           <a:p>
             <a:pPr>
-              <a:defRPr sz="2100">
+              <a:defRPr sz="2000">
                 <a:solidFill>
                   <a:srgbClr val="222222"/>
                 </a:solidFill>
@@ -3215,7 +3213,7 @@
               </a:defRPr>
             </a:pPr>
             <a:r>
-              <a:t>From static checks to workflow-aware review comments in GitHub</a:t>
+              <a:t>Automated, context-aware code review — commented directly on GitHub</a:t>
             </a:r>
           </a:p>
         </p:txBody>
@@ -3228,8 +3226,8 @@
         </p:nvSpPr>
         <p:spPr>
           <a:xfrm>
-            <a:off x="658368" y="3383280"/>
-            <a:ext cx="10607040" cy="1463040"/>
+            <a:off x="566928" y="3154680"/>
+            <a:ext cx="11064240" cy="1463040"/>
           </a:xfrm>
           <a:prstGeom prst="roundRect">
             <a:avLst/>
@@ -3262,7 +3260,7 @@
           <a:lstStyle/>
           <a:p>
             <a:pPr algn="ctr">
-              <a:defRPr sz="2000" b="1">
+              <a:defRPr sz="1900" b="1">
                 <a:solidFill>
                   <a:srgbClr val="0E2C54"/>
                 </a:solidFill>
@@ -3270,7 +3268,7 @@
               </a:defRPr>
             </a:pPr>
             <a:r>
-              <a:t>Key message: This solution behaves like an agent — it observes PR context, reasons across specialist reviewer roles, and performs a workflow action by posting code-review comments directly into GitHub.</a:t>
+              <a:t>Key idea: This is agentic AI — not just generating text, but participating in an engineering workflow and producing accountable, line-level review actions inside GitHub.</a:t>
             </a:r>
           </a:p>
         </p:txBody>
@@ -3283,8 +3281,8 @@
         </p:nvSpPr>
         <p:spPr>
           <a:xfrm>
-            <a:off x="685800" y="6217920"/>
-            <a:ext cx="10972800" cy="274320"/>
+            <a:off x="548640" y="6309360"/>
+            <a:ext cx="10972800" cy="320040"/>
           </a:xfrm>
           <a:prstGeom prst="rect">
             <a:avLst/>
@@ -3300,13 +3298,13 @@
             <a:pPr>
               <a:defRPr sz="1100">
                 <a:solidFill>
-                  <a:srgbClr val="5A5A5A"/>
+                  <a:srgbClr val="646464"/>
                 </a:solidFill>
                 <a:latin typeface="Aptos"/>
               </a:defRPr>
             </a:pPr>
             <a:r>
-              <a:t>Demo pack generated from this project's current GitHub Action + review-agent design</a:t>
+              <a:t>Built on Gemini 2.5 Flash · GitHub Actions · Python · MVVM Android project</a:t>
             </a:r>
           </a:p>
         </p:txBody>
@@ -3345,8 +3343,8 @@
         </p:nvSpPr>
         <p:spPr>
           <a:xfrm>
-            <a:off x="502920" y="320040"/>
-            <a:ext cx="10972800" cy="731520"/>
+            <a:off x="502920" y="292608"/>
+            <a:ext cx="11155680" cy="685800"/>
           </a:xfrm>
           <a:prstGeom prst="rect">
             <a:avLst/>
@@ -3360,27 +3358,70 @@
           <a:lstStyle/>
           <a:p>
             <a:r>
-              <a:rPr sz="2800" b="1">
+              <a:rPr sz="2600" b="1">
                 <a:solidFill>
                   <a:srgbClr val="0E2C54"/>
                 </a:solidFill>
                 <a:latin typeface="Aptos"/>
               </a:rPr>
-              <a:t>Close / Ask</a:t>
-            </a:r>
-          </a:p>
-        </p:txBody>
-      </p:sp>
-      <p:sp>
-        <p:nvSpPr>
-          <p:cNvPr id="3" name="TextBox 2"/>
+              <a:t>Next Steps</a:t>
+            </a:r>
+          </a:p>
+        </p:txBody>
+      </p:sp>
+      <p:sp>
+        <p:nvSpPr>
+          <p:cNvPr id="3" name="Rectangle 2"/>
+          <p:cNvSpPr/>
+          <p:nvPr/>
+        </p:nvSpPr>
+        <p:spPr>
+          <a:xfrm>
+            <a:off x="502920" y="950976"/>
+            <a:ext cx="11155680" cy="27432"/>
+          </a:xfrm>
+          <a:prstGeom prst="rect">
+            <a:avLst/>
+          </a:prstGeom>
+          <a:solidFill>
+            <a:srgbClr val="0081A7"/>
+          </a:solidFill>
+          <a:ln>
+            <a:noFill/>
+          </a:ln>
+        </p:spPr>
+        <p:style>
+          <a:lnRef idx="1">
+            <a:schemeClr val="accent1"/>
+          </a:lnRef>
+          <a:fillRef idx="3">
+            <a:schemeClr val="accent1"/>
+          </a:fillRef>
+          <a:effectRef idx="2">
+            <a:schemeClr val="accent1"/>
+          </a:effectRef>
+          <a:fontRef idx="minor">
+            <a:schemeClr val="lt1"/>
+          </a:fontRef>
+        </p:style>
+        <p:txBody>
+          <a:bodyPr rtlCol="0" anchor="ctr"/>
+          <a:lstStyle/>
+          <a:p>
+            <a:pPr algn="ctr"/>
+          </a:p>
+        </p:txBody>
+      </p:sp>
+      <p:sp>
+        <p:nvSpPr>
+          <p:cNvPr id="4" name="TextBox 3"/>
           <p:cNvSpPr txBox="1"/>
           <p:nvPr/>
         </p:nvSpPr>
         <p:spPr>
           <a:xfrm>
-            <a:off x="731520" y="1325880"/>
-            <a:ext cx="6400800" cy="4389120"/>
+            <a:off x="548640" y="1325880"/>
+            <a:ext cx="6492240" cy="5029200"/>
           </a:xfrm>
           <a:prstGeom prst="rect">
             <a:avLst/>
@@ -3397,7 +3438,7 @@
               <a:spcAft>
                 <a:spcPts val="1000"/>
               </a:spcAft>
-              <a:defRPr sz="2200">
+              <a:defRPr sz="1900">
                 <a:solidFill>
                   <a:srgbClr val="222222"/>
                 </a:solidFill>
@@ -3405,7 +3446,7 @@
               </a:defRPr>
             </a:pPr>
             <a:r>
-              <a:t>Approve a pilot for one repo or one team.</a:t>
+              <a:t>▸  Pilot on one Android repo — run in review-only mode for 2 sprints.</a:t>
             </a:r>
           </a:p>
           <a:p>
@@ -3413,7 +3454,7 @@
               <a:spcAft>
                 <a:spcPts val="1000"/>
               </a:spcAft>
-              <a:defRPr sz="2200">
+              <a:defRPr sz="1900">
                 <a:solidFill>
                   <a:srgbClr val="222222"/>
                 </a:solidFill>
@@ -3421,7 +3462,7 @@
               </a:defRPr>
             </a:pPr>
             <a:r>
-              <a:t>Use this as a standard AI agent use case inside the SDLC.</a:t>
+              <a:t>▸  Tune the prompt files based on false-positive feedback.</a:t>
             </a:r>
           </a:p>
           <a:p>
@@ -3429,7 +3470,7 @@
               <a:spcAft>
                 <a:spcPts val="1000"/>
               </a:spcAft>
-              <a:defRPr sz="2200">
+              <a:defRPr sz="1900">
                 <a:solidFill>
                   <a:srgbClr val="222222"/>
                 </a:solidFill>
@@ -3437,21 +3478,37 @@
               </a:defRPr>
             </a:pPr>
             <a:r>
-              <a:t>Measure review turnaround time, comment usefulness, and escaped defect reduction.</a:t>
-            </a:r>
-          </a:p>
-        </p:txBody>
-      </p:sp>
-      <p:sp>
-        <p:nvSpPr>
-          <p:cNvPr id="4" name="Rounded Rectangle 3"/>
+              <a:t>▸  Track: review turnaround time, escaped defects, coverage trend.</a:t>
+            </a:r>
+          </a:p>
+          <a:p>
+            <a:pPr>
+              <a:spcAft>
+                <a:spcPts val="1000"/>
+              </a:spcAft>
+              <a:defRPr sz="1900">
+                <a:solidFill>
+                  <a:srgbClr val="222222"/>
+                </a:solidFill>
+                <a:latin typeface="Aptos"/>
+              </a:defRPr>
+            </a:pPr>
+            <a:r>
+              <a:t>▸  Templatise and roll out across additional mobile projects.</a:t>
+            </a:r>
+          </a:p>
+        </p:txBody>
+      </p:sp>
+      <p:sp>
+        <p:nvSpPr>
+          <p:cNvPr id="5" name="Rounded Rectangle 4"/>
           <p:cNvSpPr/>
           <p:nvPr/>
         </p:nvSpPr>
         <p:spPr>
           <a:xfrm>
-            <a:off x="7223760" y="3840480"/>
-            <a:ext cx="4389120" cy="1554480"/>
+            <a:off x="7315200" y="1371600"/>
+            <a:ext cx="4480560" cy="914400"/>
           </a:xfrm>
           <a:prstGeom prst="roundRect">
             <a:avLst/>
@@ -3483,8 +3540,8 @@
           <a:bodyPr rtlCol="0" anchor="ctr" wrap="square"/>
           <a:lstStyle/>
           <a:p>
-            <a:pPr algn="l">
-              <a:defRPr sz="1600" i="1">
+            <a:pPr algn="ctr">
+              <a:defRPr sz="1500" b="1">
                 <a:solidFill>
                   <a:srgbClr val="0E2C54"/>
                 </a:solidFill>
@@ -3492,7 +3549,7 @@
               </a:defRPr>
             </a:pPr>
             <a:r>
-              <a:t>This is a practical example of agentic AI: not just generating text, but participating in an engineering workflow and producing accountable review actions.</a:t>
+              <a:t>"This is practical agentic AI: not generating text, but participating in an engineering workflow and producing accountable review actions."</a:t>
             </a:r>
           </a:p>
         </p:txBody>
@@ -3531,8 +3588,8 @@
         </p:nvSpPr>
         <p:spPr>
           <a:xfrm>
-            <a:off x="502920" y="320040"/>
-            <a:ext cx="10972800" cy="731520"/>
+            <a:off x="502920" y="292608"/>
+            <a:ext cx="11155680" cy="685800"/>
           </a:xfrm>
           <a:prstGeom prst="rect">
             <a:avLst/>
@@ -3546,27 +3603,70 @@
           <a:lstStyle/>
           <a:p>
             <a:r>
-              <a:rPr sz="2800" b="1">
+              <a:rPr sz="2600" b="1">
                 <a:solidFill>
                   <a:srgbClr val="0E2C54"/>
                 </a:solidFill>
                 <a:latin typeface="Aptos"/>
               </a:rPr>
-              <a:t>Problem We Are Solving</a:t>
-            </a:r>
-          </a:p>
-        </p:txBody>
-      </p:sp>
-      <p:sp>
-        <p:nvSpPr>
-          <p:cNvPr id="3" name="TextBox 2"/>
+              <a:t>The Problem</a:t>
+            </a:r>
+          </a:p>
+        </p:txBody>
+      </p:sp>
+      <p:sp>
+        <p:nvSpPr>
+          <p:cNvPr id="3" name="Rectangle 2"/>
+          <p:cNvSpPr/>
+          <p:nvPr/>
+        </p:nvSpPr>
+        <p:spPr>
+          <a:xfrm>
+            <a:off x="502920" y="950976"/>
+            <a:ext cx="11155680" cy="27432"/>
+          </a:xfrm>
+          <a:prstGeom prst="rect">
+            <a:avLst/>
+          </a:prstGeom>
+          <a:solidFill>
+            <a:srgbClr val="0081A7"/>
+          </a:solidFill>
+          <a:ln>
+            <a:noFill/>
+          </a:ln>
+        </p:spPr>
+        <p:style>
+          <a:lnRef idx="1">
+            <a:schemeClr val="accent1"/>
+          </a:lnRef>
+          <a:fillRef idx="3">
+            <a:schemeClr val="accent1"/>
+          </a:fillRef>
+          <a:effectRef idx="2">
+            <a:schemeClr val="accent1"/>
+          </a:effectRef>
+          <a:fontRef idx="minor">
+            <a:schemeClr val="lt1"/>
+          </a:fontRef>
+        </p:style>
+        <p:txBody>
+          <a:bodyPr rtlCol="0" anchor="ctr"/>
+          <a:lstStyle/>
+          <a:p>
+            <a:pPr algn="ctr"/>
+          </a:p>
+        </p:txBody>
+      </p:sp>
+      <p:sp>
+        <p:nvSpPr>
+          <p:cNvPr id="4" name="TextBox 3"/>
           <p:cNvSpPr txBox="1"/>
           <p:nvPr/>
         </p:nvSpPr>
         <p:spPr>
           <a:xfrm>
-            <a:off x="731520" y="1325880"/>
-            <a:ext cx="6400800" cy="4389120"/>
+            <a:off x="548640" y="1325880"/>
+            <a:ext cx="11247120" cy="5029200"/>
           </a:xfrm>
           <a:prstGeom prst="rect">
             <a:avLst/>
@@ -3583,7 +3683,7 @@
               <a:spcAft>
                 <a:spcPts val="1000"/>
               </a:spcAft>
-              <a:defRPr sz="2200">
+              <a:defRPr sz="1900">
                 <a:solidFill>
                   <a:srgbClr val="222222"/>
                 </a:solidFill>
@@ -3591,7 +3691,7 @@
               </a:defRPr>
             </a:pPr>
             <a:r>
-              <a:t>Manual PR review is high-value but repetitive: lint, hardcoded values, architecture drift, security checks, and test quality.</a:t>
+              <a:t>▸  Manual reviews are slow — developers wait hours or days for feedback.</a:t>
             </a:r>
           </a:p>
           <a:p>
@@ -3599,7 +3699,7 @@
               <a:spcAft>
                 <a:spcPts val="1000"/>
               </a:spcAft>
-              <a:defRPr sz="2200">
+              <a:defRPr sz="1900">
                 <a:solidFill>
                   <a:srgbClr val="222222"/>
                 </a:solidFill>
@@ -3607,7 +3707,7 @@
               </a:defRPr>
             </a:pPr>
             <a:r>
-              <a:t>Important issues are often found late, after reviewer time is already spent.</a:t>
+              <a:t>▸  Quality varies by reviewer — same mistakes get through on different PRs.</a:t>
             </a:r>
           </a:p>
           <a:p>
@@ -3615,7 +3715,7 @@
               <a:spcAft>
                 <a:spcPts val="1000"/>
               </a:spcAft>
-              <a:defRPr sz="2200">
+              <a:defRPr sz="1900">
                 <a:solidFill>
                   <a:srgbClr val="222222"/>
                 </a:solidFill>
@@ -3623,7 +3723,7 @@
               </a:defRPr>
             </a:pPr>
             <a:r>
-              <a:t>Generic AI summaries are helpful, but they do not automatically operate inside the delivery workflow.</a:t>
+              <a:t>▸  Repetitive checks waste senior engineer time: lint, magic numbers, hardcoded values.</a:t>
             </a:r>
           </a:p>
           <a:p>
@@ -3631,7 +3731,7 @@
               <a:spcAft>
                 <a:spcPts val="1000"/>
               </a:spcAft>
-              <a:defRPr sz="2200">
+              <a:defRPr sz="1900">
                 <a:solidFill>
                   <a:srgbClr val="222222"/>
                 </a:solidFill>
@@ -3639,7 +3739,7 @@
               </a:defRPr>
             </a:pPr>
             <a:r>
-              <a:t>We need review assistance that is contextual, consistent, and actionable at the exact line of change.</a:t>
+              <a:t>▸  Test-coverage gaps go unnoticed until production.</a:t>
             </a:r>
           </a:p>
         </p:txBody>
@@ -3678,8 +3778,8 @@
         </p:nvSpPr>
         <p:spPr>
           <a:xfrm>
-            <a:off x="502920" y="320040"/>
-            <a:ext cx="10972800" cy="731520"/>
+            <a:off x="502920" y="292608"/>
+            <a:ext cx="11155680" cy="685800"/>
           </a:xfrm>
           <a:prstGeom prst="rect">
             <a:avLst/>
@@ -3693,27 +3793,70 @@
           <a:lstStyle/>
           <a:p>
             <a:r>
-              <a:rPr sz="2800" b="1">
+              <a:rPr sz="2600" b="1">
                 <a:solidFill>
                   <a:srgbClr val="0E2C54"/>
                 </a:solidFill>
                 <a:latin typeface="Aptos"/>
               </a:rPr>
-              <a:t>Why This Is Agentic — Not Just Prompting</a:t>
-            </a:r>
-          </a:p>
-        </p:txBody>
-      </p:sp>
-      <p:sp>
-        <p:nvSpPr>
-          <p:cNvPr id="3" name="TextBox 2"/>
+              <a:t>Why This Is an Agent — Not Just a Prompt</a:t>
+            </a:r>
+          </a:p>
+        </p:txBody>
+      </p:sp>
+      <p:sp>
+        <p:nvSpPr>
+          <p:cNvPr id="3" name="Rectangle 2"/>
+          <p:cNvSpPr/>
+          <p:nvPr/>
+        </p:nvSpPr>
+        <p:spPr>
+          <a:xfrm>
+            <a:off x="502920" y="950976"/>
+            <a:ext cx="11155680" cy="27432"/>
+          </a:xfrm>
+          <a:prstGeom prst="rect">
+            <a:avLst/>
+          </a:prstGeom>
+          <a:solidFill>
+            <a:srgbClr val="0081A7"/>
+          </a:solidFill>
+          <a:ln>
+            <a:noFill/>
+          </a:ln>
+        </p:spPr>
+        <p:style>
+          <a:lnRef idx="1">
+            <a:schemeClr val="accent1"/>
+          </a:lnRef>
+          <a:fillRef idx="3">
+            <a:schemeClr val="accent1"/>
+          </a:fillRef>
+          <a:effectRef idx="2">
+            <a:schemeClr val="accent1"/>
+          </a:effectRef>
+          <a:fontRef idx="minor">
+            <a:schemeClr val="lt1"/>
+          </a:fontRef>
+        </p:style>
+        <p:txBody>
+          <a:bodyPr rtlCol="0" anchor="ctr"/>
+          <a:lstStyle/>
+          <a:p>
+            <a:pPr algn="ctr"/>
+          </a:p>
+        </p:txBody>
+      </p:sp>
+      <p:sp>
+        <p:nvSpPr>
+          <p:cNvPr id="4" name="TextBox 3"/>
           <p:cNvSpPr txBox="1"/>
           <p:nvPr/>
         </p:nvSpPr>
         <p:spPr>
           <a:xfrm>
-            <a:off x="731520" y="1325880"/>
-            <a:ext cx="6400800" cy="4389120"/>
+            <a:off x="548640" y="1325880"/>
+            <a:ext cx="6492240" cy="5029200"/>
           </a:xfrm>
           <a:prstGeom prst="rect">
             <a:avLst/>
@@ -3730,7 +3873,7 @@
               <a:spcAft>
                 <a:spcPts val="1000"/>
               </a:spcAft>
-              <a:defRPr sz="2200">
+              <a:defRPr sz="1900">
                 <a:solidFill>
                   <a:srgbClr val="222222"/>
                 </a:solidFill>
@@ -3738,7 +3881,7 @@
               </a:defRPr>
             </a:pPr>
             <a:r>
-              <a:t>Trigger-aware: starts automatically when a pull request is opened or updated.</a:t>
+              <a:t>▸  Trigger-aware: starts automatically when a PR is opened or updated.</a:t>
             </a:r>
           </a:p>
           <a:p>
@@ -3746,7 +3889,7 @@
               <a:spcAft>
                 <a:spcPts val="1000"/>
               </a:spcAft>
-              <a:defRPr sz="2200">
+              <a:defRPr sz="1900">
                 <a:solidFill>
                   <a:srgbClr val="222222"/>
                 </a:solidFill>
@@ -3754,7 +3897,7 @@
               </a:defRPr>
             </a:pPr>
             <a:r>
-              <a:t>Context-aware: reads PR diff, Android lint output, and unit-test coverage context.</a:t>
+              <a:t>▸  Context-aware: reads PR diff, lint output, and test coverage.</a:t>
             </a:r>
           </a:p>
           <a:p>
@@ -3762,7 +3905,7 @@
               <a:spcAft>
                 <a:spcPts val="1000"/>
               </a:spcAft>
-              <a:defRPr sz="2200">
+              <a:defRPr sz="1900">
                 <a:solidFill>
                   <a:srgbClr val="222222"/>
                 </a:solidFill>
@@ -3770,7 +3913,7 @@
               </a:defRPr>
             </a:pPr>
             <a:r>
-              <a:t>Role-aware: evaluates the change through specialist reviewer personas.</a:t>
+              <a:t>▸  Role-aware: reasons through specialist reviewer personas (Architecture, UI, Security, QA).</a:t>
             </a:r>
           </a:p>
           <a:p>
@@ -3778,7 +3921,7 @@
               <a:spcAft>
                 <a:spcPts val="1000"/>
               </a:spcAft>
-              <a:defRPr sz="2200">
+              <a:defRPr sz="1900">
                 <a:solidFill>
                   <a:srgbClr val="222222"/>
                 </a:solidFill>
@@ -3786,7 +3929,7 @@
               </a:defRPr>
             </a:pPr>
             <a:r>
-              <a:t>Action-oriented: converts findings into structured output and posts review comments back into GitHub.</a:t>
+              <a:t>▸  Action-oriented: posts structured review comments at the exact line of code.</a:t>
             </a:r>
           </a:p>
           <a:p>
@@ -3794,7 +3937,7 @@
               <a:spcAft>
                 <a:spcPts val="1000"/>
               </a:spcAft>
-              <a:defRPr sz="2200">
+              <a:defRPr sz="1900">
                 <a:solidFill>
                   <a:srgbClr val="222222"/>
                 </a:solidFill>
@@ -3802,7 +3945,62 @@
               </a:defRPr>
             </a:pPr>
             <a:r>
-              <a:t>Feedback-loop ready: developers fix issues in the same PR flow and re-run the agent on the next push.</a:t>
+              <a:t>▸  Feedback-loop: developer fixes → pushes → agent re-reviews in the same PR.</a:t>
+            </a:r>
+          </a:p>
+        </p:txBody>
+      </p:sp>
+      <p:sp>
+        <p:nvSpPr>
+          <p:cNvPr id="5" name="Rounded Rectangle 4"/>
+          <p:cNvSpPr/>
+          <p:nvPr/>
+        </p:nvSpPr>
+        <p:spPr>
+          <a:xfrm>
+            <a:off x="7315200" y="1371600"/>
+            <a:ext cx="4480560" cy="914400"/>
+          </a:xfrm>
+          <a:prstGeom prst="roundRect">
+            <a:avLst/>
+          </a:prstGeom>
+          <a:solidFill>
+            <a:srgbClr val="E5EEF6"/>
+          </a:solidFill>
+          <a:ln>
+            <a:solidFill>
+              <a:srgbClr val="0081A7"/>
+            </a:solidFill>
+          </a:ln>
+        </p:spPr>
+        <p:style>
+          <a:lnRef idx="1">
+            <a:schemeClr val="accent1"/>
+          </a:lnRef>
+          <a:fillRef idx="3">
+            <a:schemeClr val="accent1"/>
+          </a:fillRef>
+          <a:effectRef idx="2">
+            <a:schemeClr val="accent1"/>
+          </a:effectRef>
+          <a:fontRef idx="minor">
+            <a:schemeClr val="lt1"/>
+          </a:fontRef>
+        </p:style>
+        <p:txBody>
+          <a:bodyPr rtlCol="0" anchor="ctr" wrap="square"/>
+          <a:lstStyle/>
+          <a:p>
+            <a:pPr algn="ctr">
+              <a:defRPr sz="1500" b="1">
+                <a:solidFill>
+                  <a:srgbClr val="0E2C54"/>
+                </a:solidFill>
+                <a:latin typeface="Aptos"/>
+              </a:defRPr>
+            </a:pPr>
+            <a:r>
+              <a:t>"The agent behaves like a Staff Engineer: it reads context, reasons across specialties, and acts where the developer needs to."</a:t>
             </a:r>
           </a:p>
         </p:txBody>
@@ -3841,8 +4039,8 @@
         </p:nvSpPr>
         <p:spPr>
           <a:xfrm>
-            <a:off x="502920" y="320040"/>
-            <a:ext cx="10972800" cy="731520"/>
+            <a:off x="502920" y="292608"/>
+            <a:ext cx="11155680" cy="685800"/>
           </a:xfrm>
           <a:prstGeom prst="rect">
             <a:avLst/>
@@ -3856,7 +4054,7 @@
           <a:lstStyle/>
           <a:p>
             <a:r>
-              <a:rPr sz="2800" b="1">
+              <a:rPr sz="2600" b="1">
                 <a:solidFill>
                   <a:srgbClr val="0E2C54"/>
                 </a:solidFill>
@@ -3867,9 +4065,52 @@
           </a:p>
         </p:txBody>
       </p:sp>
+      <p:sp>
+        <p:nvSpPr>
+          <p:cNvPr id="3" name="Rectangle 2"/>
+          <p:cNvSpPr/>
+          <p:nvPr/>
+        </p:nvSpPr>
+        <p:spPr>
+          <a:xfrm>
+            <a:off x="502920" y="950976"/>
+            <a:ext cx="11155680" cy="27432"/>
+          </a:xfrm>
+          <a:prstGeom prst="rect">
+            <a:avLst/>
+          </a:prstGeom>
+          <a:solidFill>
+            <a:srgbClr val="0081A7"/>
+          </a:solidFill>
+          <a:ln>
+            <a:noFill/>
+          </a:ln>
+        </p:spPr>
+        <p:style>
+          <a:lnRef idx="1">
+            <a:schemeClr val="accent1"/>
+          </a:lnRef>
+          <a:fillRef idx="3">
+            <a:schemeClr val="accent1"/>
+          </a:fillRef>
+          <a:effectRef idx="2">
+            <a:schemeClr val="accent1"/>
+          </a:effectRef>
+          <a:fontRef idx="minor">
+            <a:schemeClr val="lt1"/>
+          </a:fontRef>
+        </p:style>
+        <p:txBody>
+          <a:bodyPr rtlCol="0" anchor="ctr"/>
+          <a:lstStyle/>
+          <a:p>
+            <a:pPr algn="ctr"/>
+          </a:p>
+        </p:txBody>
+      </p:sp>
       <p:pic>
         <p:nvPicPr>
-          <p:cNvPr id="3" name="Picture 2" descr="agentic-review-flow.png"/>
+          <p:cNvPr id="4" name="Picture 3" descr="agentic-review-flow.png"/>
           <p:cNvPicPr>
             <a:picLocks noChangeAspect="1"/>
           </p:cNvPicPr>
@@ -3883,8 +4124,8 @@
         </p:blipFill>
         <p:spPr>
           <a:xfrm>
-            <a:off x="411480" y="1325880"/>
-            <a:ext cx="11292840" cy="6352222"/>
+            <a:off x="365760" y="1234440"/>
+            <a:ext cx="11430000" cy="6143625"/>
           </a:xfrm>
           <a:prstGeom prst="rect">
             <a:avLst/>
@@ -3893,14 +4134,14 @@
       </p:pic>
       <p:sp>
         <p:nvSpPr>
-          <p:cNvPr id="4" name="TextBox 3"/>
+          <p:cNvPr id="5" name="TextBox 4"/>
           <p:cNvSpPr txBox="1"/>
           <p:nvPr/>
         </p:nvSpPr>
         <p:spPr>
           <a:xfrm>
-            <a:off x="640080" y="5943600"/>
-            <a:ext cx="10607040" cy="411480"/>
+            <a:off x="548640" y="6263640"/>
+            <a:ext cx="10972800" cy="365760"/>
           </a:xfrm>
           <a:prstGeom prst="rect">
             <a:avLst/>
@@ -3914,15 +4155,15 @@
           <a:lstStyle/>
           <a:p>
             <a:pPr>
-              <a:defRPr sz="1300">
-                <a:solidFill>
-                  <a:srgbClr val="5A5A5A"/>
+              <a:defRPr sz="1200">
+                <a:solidFill>
+                  <a:srgbClr val="646464"/>
                 </a:solidFill>
                 <a:latin typeface="Aptos"/>
               </a:defRPr>
             </a:pPr>
             <a:r>
-              <a:t>Current workflow: PR event → context collection → master reviewer → specialist reasoning → structured findings → inline PR comments</a:t>
+              <a:t>PR event → diff + lint + coverage collection → Gemini master reviewer → specialist sub-agents → structured findings → GitHub inline comments</a:t>
             </a:r>
           </a:p>
         </p:txBody>
@@ -3961,8 +4202,8 @@
         </p:nvSpPr>
         <p:spPr>
           <a:xfrm>
-            <a:off x="502920" y="320040"/>
-            <a:ext cx="10972800" cy="731520"/>
+            <a:off x="502920" y="292608"/>
+            <a:ext cx="11155680" cy="685800"/>
           </a:xfrm>
           <a:prstGeom prst="rect">
             <a:avLst/>
@@ -3976,27 +4217,70 @@
           <a:lstStyle/>
           <a:p>
             <a:r>
-              <a:rPr sz="2800" b="1">
+              <a:rPr sz="2600" b="1">
                 <a:solidFill>
                   <a:srgbClr val="0E2C54"/>
                 </a:solidFill>
                 <a:latin typeface="Aptos"/>
               </a:rPr>
-              <a:t>Architecture of the Solution</a:t>
-            </a:r>
-          </a:p>
-        </p:txBody>
-      </p:sp>
-      <p:sp>
-        <p:nvSpPr>
-          <p:cNvPr id="3" name="Rounded Rectangle 2"/>
+              <a:t>How It Is Built</a:t>
+            </a:r>
+          </a:p>
+        </p:txBody>
+      </p:sp>
+      <p:sp>
+        <p:nvSpPr>
+          <p:cNvPr id="3" name="Rectangle 2"/>
           <p:cNvSpPr/>
           <p:nvPr/>
         </p:nvSpPr>
         <p:spPr>
           <a:xfrm>
-            <a:off x="548640" y="1417320"/>
-            <a:ext cx="2834640" cy="4389120"/>
+            <a:off x="502920" y="950976"/>
+            <a:ext cx="11155680" cy="27432"/>
+          </a:xfrm>
+          <a:prstGeom prst="rect">
+            <a:avLst/>
+          </a:prstGeom>
+          <a:solidFill>
+            <a:srgbClr val="0081A7"/>
+          </a:solidFill>
+          <a:ln>
+            <a:noFill/>
+          </a:ln>
+        </p:spPr>
+        <p:style>
+          <a:lnRef idx="1">
+            <a:schemeClr val="accent1"/>
+          </a:lnRef>
+          <a:fillRef idx="3">
+            <a:schemeClr val="accent1"/>
+          </a:fillRef>
+          <a:effectRef idx="2">
+            <a:schemeClr val="accent1"/>
+          </a:effectRef>
+          <a:fontRef idx="minor">
+            <a:schemeClr val="lt1"/>
+          </a:fontRef>
+        </p:style>
+        <p:txBody>
+          <a:bodyPr rtlCol="0" anchor="ctr"/>
+          <a:lstStyle/>
+          <a:p>
+            <a:pPr algn="ctr"/>
+          </a:p>
+        </p:txBody>
+      </p:sp>
+      <p:sp>
+        <p:nvSpPr>
+          <p:cNvPr id="4" name="Rounded Rectangle 3"/>
+          <p:cNvSpPr/>
+          <p:nvPr/>
+        </p:nvSpPr>
+        <p:spPr>
+          <a:xfrm>
+            <a:off x="457200" y="1325880"/>
+            <a:ext cx="3200400" cy="4846320"/>
           </a:xfrm>
           <a:prstGeom prst="roundRect">
             <a:avLst/>
@@ -4029,7 +4313,7 @@
           <a:lstStyle/>
           <a:p>
             <a:pPr algn="ctr">
-              <a:defRPr sz="2000" b="1">
+              <a:defRPr sz="1800" b="1">
                 <a:solidFill>
                   <a:srgbClr val="0E2C54"/>
                 </a:solidFill>
@@ -4037,12 +4321,15 @@
               </a:defRPr>
             </a:pPr>
             <a:r>
-              <a:t>1. Orchestration Layer</a:t>
+              <a:t>① Orchestration</a:t>
             </a:r>
           </a:p>
           <a:p>
             <a:pPr>
-              <a:defRPr sz="1500">
+              <a:spcBef>
+                <a:spcPts val="400"/>
+              </a:spcBef>
+              <a:defRPr sz="1400">
                 <a:solidFill>
                   <a:srgbClr val="222222"/>
                 </a:solidFill>
@@ -4050,12 +4337,15 @@
               </a:defRPr>
             </a:pPr>
             <a:r>
-              <a:t>GitHub Actions workflow (`.github/workflows/ai-pr-reviewer.yml`)</a:t>
+              <a:t>  • GitHub Actions workflow</a:t>
             </a:r>
           </a:p>
           <a:p>
             <a:pPr>
-              <a:defRPr sz="1500">
+              <a:spcBef>
+                <a:spcPts val="400"/>
+              </a:spcBef>
+              <a:defRPr sz="1400">
                 <a:solidFill>
                   <a:srgbClr val="222222"/>
                 </a:solidFill>
@@ -4063,12 +4353,15 @@
               </a:defRPr>
             </a:pPr>
             <a:r>
-              <a:t>Diff generation (`pr_diff.patch`)</a:t>
+              <a:t>  • Diff (pr_diff.patch)</a:t>
             </a:r>
           </a:p>
           <a:p>
             <a:pPr>
-              <a:defRPr sz="1500">
+              <a:spcBef>
+                <a:spcPts val="400"/>
+              </a:spcBef>
+              <a:defRPr sz="1400">
                 <a:solidFill>
                   <a:srgbClr val="222222"/>
                 </a:solidFill>
@@ -4076,12 +4369,15 @@
               </a:defRPr>
             </a:pPr>
             <a:r>
-              <a:t>Lint + coverage context collection</a:t>
+              <a:t>  • Android Lint context</a:t>
             </a:r>
           </a:p>
           <a:p>
             <a:pPr>
-              <a:defRPr sz="1500">
+              <a:spcBef>
+                <a:spcPts val="400"/>
+              </a:spcBef>
+              <a:defRPr sz="1400">
                 <a:solidFill>
                   <a:srgbClr val="222222"/>
                 </a:solidFill>
@@ -4089,21 +4385,37 @@
               </a:defRPr>
             </a:pPr>
             <a:r>
-              <a:t>Python controller (`.github/scripts/run_agent.py`)</a:t>
-            </a:r>
-          </a:p>
-        </p:txBody>
-      </p:sp>
-      <p:sp>
-        <p:nvSpPr>
-          <p:cNvPr id="4" name="Rounded Rectangle 3"/>
+              <a:t>  • JaCoCo coverage XML</a:t>
+            </a:r>
+          </a:p>
+          <a:p>
+            <a:pPr>
+              <a:spcBef>
+                <a:spcPts val="400"/>
+              </a:spcBef>
+              <a:defRPr sz="1400">
+                <a:solidFill>
+                  <a:srgbClr val="222222"/>
+                </a:solidFill>
+                <a:latin typeface="Aptos"/>
+              </a:defRPr>
+            </a:pPr>
+            <a:r>
+              <a:t>  • run_agent.py controller</a:t>
+            </a:r>
+          </a:p>
+        </p:txBody>
+      </p:sp>
+      <p:sp>
+        <p:nvSpPr>
+          <p:cNvPr id="5" name="Rounded Rectangle 4"/>
           <p:cNvSpPr/>
           <p:nvPr/>
         </p:nvSpPr>
         <p:spPr>
           <a:xfrm>
-            <a:off x="3977639" y="1417320"/>
-            <a:ext cx="2834640" cy="4389120"/>
+            <a:off x="4069080" y="1325880"/>
+            <a:ext cx="3200400" cy="4846320"/>
           </a:xfrm>
           <a:prstGeom prst="roundRect">
             <a:avLst/>
@@ -4136,7 +4448,7 @@
           <a:lstStyle/>
           <a:p>
             <a:pPr algn="ctr">
-              <a:defRPr sz="2000" b="1">
+              <a:defRPr sz="1800" b="1">
                 <a:solidFill>
                   <a:srgbClr val="0E2C54"/>
                 </a:solidFill>
@@ -4144,12 +4456,15 @@
               </a:defRPr>
             </a:pPr>
             <a:r>
-              <a:t>2. Intelligence Layer</a:t>
+              <a:t>② Intelligence</a:t>
             </a:r>
           </a:p>
           <a:p>
             <a:pPr>
-              <a:defRPr sz="1500">
+              <a:spcBef>
+                <a:spcPts val="400"/>
+              </a:spcBef>
+              <a:defRPr sz="1400">
                 <a:solidFill>
                   <a:srgbClr val="222222"/>
                 </a:solidFill>
@@ -4157,12 +4472,15 @@
               </a:defRPr>
             </a:pPr>
             <a:r>
-              <a:t>`master-reviewer-agent.md` as lead reviewer</a:t>
+              <a:t>  • master-reviewer-agent.md</a:t>
             </a:r>
           </a:p>
           <a:p>
             <a:pPr>
-              <a:defRPr sz="1500">
+              <a:spcBef>
+                <a:spcPts val="400"/>
+              </a:spcBef>
+              <a:defRPr sz="1400">
                 <a:solidFill>
                   <a:srgbClr val="222222"/>
                 </a:solidFill>
@@ -4170,12 +4488,15 @@
               </a:defRPr>
             </a:pPr>
             <a:r>
-              <a:t>Architecture / Logic sub-agent</a:t>
+              <a:t>  • arch-logic-agent.md</a:t>
             </a:r>
           </a:p>
           <a:p>
             <a:pPr>
-              <a:defRPr sz="1500">
+              <a:spcBef>
+                <a:spcPts val="400"/>
+              </a:spcBef>
+              <a:defRPr sz="1400">
                 <a:solidFill>
                   <a:srgbClr val="222222"/>
                 </a:solidFill>
@@ -4183,12 +4504,15 @@
               </a:defRPr>
             </a:pPr>
             <a:r>
-              <a:t>Compose UI sub-agent</a:t>
+              <a:t>  • compose-ui-agent.md</a:t>
             </a:r>
           </a:p>
           <a:p>
             <a:pPr>
-              <a:defRPr sz="1500">
+              <a:spcBef>
+                <a:spcPts val="400"/>
+              </a:spcBef>
+              <a:defRPr sz="1400">
                 <a:solidFill>
                   <a:srgbClr val="222222"/>
                 </a:solidFill>
@@ -4196,12 +4520,15 @@
               </a:defRPr>
             </a:pPr>
             <a:r>
-              <a:t>Security / Config sub-agent</a:t>
+              <a:t>  • security-config-agent.md</a:t>
             </a:r>
           </a:p>
           <a:p>
             <a:pPr>
-              <a:defRPr sz="1500">
+              <a:spcBef>
+                <a:spcPts val="400"/>
+              </a:spcBef>
+              <a:defRPr sz="1400">
                 <a:solidFill>
                   <a:srgbClr val="222222"/>
                 </a:solidFill>
@@ -4209,21 +4536,21 @@
               </a:defRPr>
             </a:pPr>
             <a:r>
-              <a:t>Test / QA sub-agent</a:t>
-            </a:r>
-          </a:p>
-        </p:txBody>
-      </p:sp>
-      <p:sp>
-        <p:nvSpPr>
-          <p:cNvPr id="5" name="Rounded Rectangle 4"/>
+              <a:t>  • test-qa-agent.md</a:t>
+            </a:r>
+          </a:p>
+        </p:txBody>
+      </p:sp>
+      <p:sp>
+        <p:nvSpPr>
+          <p:cNvPr id="6" name="Rounded Rectangle 5"/>
           <p:cNvSpPr/>
           <p:nvPr/>
         </p:nvSpPr>
         <p:spPr>
           <a:xfrm>
-            <a:off x="7406640" y="1417320"/>
-            <a:ext cx="2834640" cy="4389120"/>
+            <a:off x="7680960" y="1325880"/>
+            <a:ext cx="3200400" cy="4846320"/>
           </a:xfrm>
           <a:prstGeom prst="roundRect">
             <a:avLst/>
@@ -4256,7 +4583,7 @@
           <a:lstStyle/>
           <a:p>
             <a:pPr algn="ctr">
-              <a:defRPr sz="2000" b="1">
+              <a:defRPr sz="1800" b="1">
                 <a:solidFill>
                   <a:srgbClr val="0E2C54"/>
                 </a:solidFill>
@@ -4264,12 +4591,15 @@
               </a:defRPr>
             </a:pPr>
             <a:r>
-              <a:t>3. Output Layer</a:t>
+              <a:t>③ Output</a:t>
             </a:r>
           </a:p>
           <a:p>
             <a:pPr>
-              <a:defRPr sz="1500">
+              <a:spcBef>
+                <a:spcPts val="400"/>
+              </a:spcBef>
+              <a:defRPr sz="1400">
                 <a:solidFill>
                   <a:srgbClr val="222222"/>
                 </a:solidFill>
@@ -4277,12 +4607,15 @@
               </a:defRPr>
             </a:pPr>
             <a:r>
-              <a:t>Structured XML findings</a:t>
+              <a:t>  • Structured XML findings</a:t>
             </a:r>
           </a:p>
           <a:p>
             <a:pPr>
-              <a:defRPr sz="1500">
+              <a:spcBef>
+                <a:spcPts val="400"/>
+              </a:spcBef>
+              <a:defRPr sz="1400">
                 <a:solidFill>
                   <a:srgbClr val="222222"/>
                 </a:solidFill>
@@ -4290,12 +4623,15 @@
               </a:defRPr>
             </a:pPr>
             <a:r>
-              <a:t>Severity ordering</a:t>
+              <a:t>  • Severity ranking</a:t>
             </a:r>
           </a:p>
           <a:p>
             <a:pPr>
-              <a:defRPr sz="1500">
+              <a:spcBef>
+                <a:spcPts val="400"/>
+              </a:spcBef>
+              <a:defRPr sz="1400">
                 <a:solidFill>
                   <a:srgbClr val="222222"/>
                 </a:solidFill>
@@ -4303,12 +4639,15 @@
               </a:defRPr>
             </a:pPr>
             <a:r>
-              <a:t>Exact file + line extraction</a:t>
+              <a:t>  • Exact file + line pinning</a:t>
             </a:r>
           </a:p>
           <a:p>
             <a:pPr>
-              <a:defRPr sz="1500">
+              <a:spcBef>
+                <a:spcPts val="400"/>
+              </a:spcBef>
+              <a:defRPr sz="1400">
                 <a:solidFill>
                   <a:srgbClr val="222222"/>
                 </a:solidFill>
@@ -4316,12 +4655,15 @@
               </a:defRPr>
             </a:pPr>
             <a:r>
-              <a:t>Inline GitHub review comments</a:t>
+              <a:t>  • Inline GitHub comments</a:t>
             </a:r>
           </a:p>
           <a:p>
             <a:pPr>
-              <a:defRPr sz="1500">
+              <a:spcBef>
+                <a:spcPts val="400"/>
+              </a:spcBef>
+              <a:defRPr sz="1400">
                 <a:solidFill>
                   <a:srgbClr val="222222"/>
                 </a:solidFill>
@@ -4329,7 +4671,7 @@
               </a:defRPr>
             </a:pPr>
             <a:r>
-              <a:t>Coverage alerts for business-logic files below 75%</a:t>
+              <a:t>  • Coverage alerts (&lt; 75 %)</a:t>
             </a:r>
           </a:p>
         </p:txBody>
@@ -4368,8 +4710,8 @@
         </p:nvSpPr>
         <p:spPr>
           <a:xfrm>
-            <a:off x="502920" y="320040"/>
-            <a:ext cx="10972800" cy="731520"/>
+            <a:off x="502920" y="292608"/>
+            <a:ext cx="11155680" cy="685800"/>
           </a:xfrm>
           <a:prstGeom prst="rect">
             <a:avLst/>
@@ -4383,27 +4725,70 @@
           <a:lstStyle/>
           <a:p>
             <a:r>
-              <a:rPr sz="2800" b="1">
+              <a:rPr sz="2600" b="1">
                 <a:solidFill>
                   <a:srgbClr val="0E2C54"/>
                 </a:solidFill>
                 <a:latin typeface="Aptos"/>
               </a:rPr>
-              <a:t>What This Agent Checks</a:t>
-            </a:r>
-          </a:p>
-        </p:txBody>
-      </p:sp>
-      <p:sp>
-        <p:nvSpPr>
-          <p:cNvPr id="3" name="TextBox 2"/>
+              <a:t>What the Agent Reviews</a:t>
+            </a:r>
+          </a:p>
+        </p:txBody>
+      </p:sp>
+      <p:sp>
+        <p:nvSpPr>
+          <p:cNvPr id="3" name="Rectangle 2"/>
+          <p:cNvSpPr/>
+          <p:nvPr/>
+        </p:nvSpPr>
+        <p:spPr>
+          <a:xfrm>
+            <a:off x="502920" y="950976"/>
+            <a:ext cx="11155680" cy="27432"/>
+          </a:xfrm>
+          <a:prstGeom prst="rect">
+            <a:avLst/>
+          </a:prstGeom>
+          <a:solidFill>
+            <a:srgbClr val="0081A7"/>
+          </a:solidFill>
+          <a:ln>
+            <a:noFill/>
+          </a:ln>
+        </p:spPr>
+        <p:style>
+          <a:lnRef idx="1">
+            <a:schemeClr val="accent1"/>
+          </a:lnRef>
+          <a:fillRef idx="3">
+            <a:schemeClr val="accent1"/>
+          </a:fillRef>
+          <a:effectRef idx="2">
+            <a:schemeClr val="accent1"/>
+          </a:effectRef>
+          <a:fontRef idx="minor">
+            <a:schemeClr val="lt1"/>
+          </a:fontRef>
+        </p:style>
+        <p:txBody>
+          <a:bodyPr rtlCol="0" anchor="ctr"/>
+          <a:lstStyle/>
+          <a:p>
+            <a:pPr algn="ctr"/>
+          </a:p>
+        </p:txBody>
+      </p:sp>
+      <p:sp>
+        <p:nvSpPr>
+          <p:cNvPr id="4" name="TextBox 3"/>
           <p:cNvSpPr txBox="1"/>
           <p:nvPr/>
         </p:nvSpPr>
         <p:spPr>
           <a:xfrm>
-            <a:off x="731520" y="1325880"/>
-            <a:ext cx="6400800" cy="4389120"/>
+            <a:off x="548640" y="1325880"/>
+            <a:ext cx="11247120" cy="5029200"/>
           </a:xfrm>
           <a:prstGeom prst="rect">
             <a:avLst/>
@@ -4420,7 +4805,7 @@
               <a:spcAft>
                 <a:spcPts val="1000"/>
               </a:spcAft>
-              <a:defRPr sz="2200">
+              <a:defRPr sz="1900">
                 <a:solidFill>
                   <a:srgbClr val="222222"/>
                 </a:solidFill>
@@ -4428,7 +4813,7 @@
               </a:defRPr>
             </a:pPr>
             <a:r>
-              <a:t>Android lint and Kotlin code quality rules</a:t>
+              <a:t>▸  Hardcoded strings, colours, magic numbers → suggests BuildConfig or resource XML.</a:t>
             </a:r>
           </a:p>
           <a:p>
@@ -4436,7 +4821,7 @@
               <a:spcAft>
                 <a:spcPts val="1000"/>
               </a:spcAft>
-              <a:defRPr sz="2200">
+              <a:defRPr sz="1900">
                 <a:solidFill>
                   <a:srgbClr val="222222"/>
                 </a:solidFill>
@@ -4444,7 +4829,7 @@
               </a:defRPr>
             </a:pPr>
             <a:r>
-              <a:t>Hardcoded strings, colors, numbers, and static literals</a:t>
+              <a:t>▸  Android Lint + Kotlin lint rules and code formatting.</a:t>
             </a:r>
           </a:p>
           <a:p>
@@ -4452,7 +4837,7 @@
               <a:spcAft>
                 <a:spcPts val="1000"/>
               </a:spcAft>
-              <a:defRPr sz="2200">
+              <a:defRPr sz="1900">
                 <a:solidFill>
                   <a:srgbClr val="222222"/>
                 </a:solidFill>
@@ -4460,7 +4845,7 @@
               </a:defRPr>
             </a:pPr>
             <a:r>
-              <a:t>Correct use of BuildConfig vs Android resources</a:t>
+              <a:t>▸  Compose UI quality, accessibility, and recomposition hygiene.</a:t>
             </a:r>
           </a:p>
           <a:p>
@@ -4468,7 +4853,7 @@
               <a:spcAft>
                 <a:spcPts val="1000"/>
               </a:spcAft>
-              <a:defRPr sz="2200">
+              <a:defRPr sz="1900">
                 <a:solidFill>
                   <a:srgbClr val="222222"/>
                 </a:solidFill>
@@ -4476,7 +4861,7 @@
               </a:defRPr>
             </a:pPr>
             <a:r>
-              <a:t>Compose UI quality, accessibility, and recomposition hygiene</a:t>
+              <a:t>▸  Architecture boundaries: ViewModel / Repository / Data layers.</a:t>
             </a:r>
           </a:p>
           <a:p>
@@ -4484,7 +4869,7 @@
               <a:spcAft>
                 <a:spcPts val="1000"/>
               </a:spcAft>
-              <a:defRPr sz="2200">
+              <a:defRPr sz="1900">
                 <a:solidFill>
                   <a:srgbClr val="222222"/>
                 </a:solidFill>
@@ -4492,7 +4877,7 @@
               </a:defRPr>
             </a:pPr>
             <a:r>
-              <a:t>Architecture boundaries across ViewModel / Repository / data layers</a:t>
+              <a:t>▸  Security risks in build scripts, API usage, and Manifest.</a:t>
             </a:r>
           </a:p>
           <a:p>
@@ -4500,7 +4885,7 @@
               <a:spcAft>
                 <a:spcPts val="1000"/>
               </a:spcAft>
-              <a:defRPr sz="2200">
+              <a:defRPr sz="1900">
                 <a:solidFill>
                   <a:srgbClr val="222222"/>
                 </a:solidFill>
@@ -4508,23 +4893,7 @@
               </a:defRPr>
             </a:pPr>
             <a:r>
-              <a:t>Security and configuration risks in build scripts and API usage</a:t>
-            </a:r>
-          </a:p>
-          <a:p>
-            <a:pPr>
-              <a:spcAft>
-                <a:spcPts val="1000"/>
-              </a:spcAft>
-              <a:defRPr sz="2200">
-                <a:solidFill>
-                  <a:srgbClr val="222222"/>
-                </a:solidFill>
-                <a:latin typeface="Aptos"/>
-              </a:defRPr>
-            </a:pPr>
-            <a:r>
-              <a:t>Testability and coverage gaps in business logic</a:t>
+              <a:t>▸  Test coverage gaps in business-logic files (Repository, UseCase).</a:t>
             </a:r>
           </a:p>
         </p:txBody>
@@ -4563,8 +4932,8 @@
         </p:nvSpPr>
         <p:spPr>
           <a:xfrm>
-            <a:off x="502920" y="320040"/>
-            <a:ext cx="10972800" cy="731520"/>
+            <a:off x="502920" y="292608"/>
+            <a:ext cx="11155680" cy="685800"/>
           </a:xfrm>
           <a:prstGeom prst="rect">
             <a:avLst/>
@@ -4578,27 +4947,70 @@
           <a:lstStyle/>
           <a:p>
             <a:r>
-              <a:rPr sz="2800" b="1">
+              <a:rPr sz="2600" b="1">
                 <a:solidFill>
                   <a:srgbClr val="0E2C54"/>
                 </a:solidFill>
                 <a:latin typeface="Aptos"/>
               </a:rPr>
-              <a:t>What the Demo Will Show Live</a:t>
-            </a:r>
-          </a:p>
-        </p:txBody>
-      </p:sp>
-      <p:sp>
-        <p:nvSpPr>
-          <p:cNvPr id="3" name="TextBox 2"/>
+              <a:t>What the Live Demo Shows</a:t>
+            </a:r>
+          </a:p>
+        </p:txBody>
+      </p:sp>
+      <p:sp>
+        <p:nvSpPr>
+          <p:cNvPr id="3" name="Rectangle 2"/>
+          <p:cNvSpPr/>
+          <p:nvPr/>
+        </p:nvSpPr>
+        <p:spPr>
+          <a:xfrm>
+            <a:off x="502920" y="950976"/>
+            <a:ext cx="11155680" cy="27432"/>
+          </a:xfrm>
+          <a:prstGeom prst="rect">
+            <a:avLst/>
+          </a:prstGeom>
+          <a:solidFill>
+            <a:srgbClr val="0081A7"/>
+          </a:solidFill>
+          <a:ln>
+            <a:noFill/>
+          </a:ln>
+        </p:spPr>
+        <p:style>
+          <a:lnRef idx="1">
+            <a:schemeClr val="accent1"/>
+          </a:lnRef>
+          <a:fillRef idx="3">
+            <a:schemeClr val="accent1"/>
+          </a:fillRef>
+          <a:effectRef idx="2">
+            <a:schemeClr val="accent1"/>
+          </a:effectRef>
+          <a:fontRef idx="minor">
+            <a:schemeClr val="lt1"/>
+          </a:fontRef>
+        </p:style>
+        <p:txBody>
+          <a:bodyPr rtlCol="0" anchor="ctr"/>
+          <a:lstStyle/>
+          <a:p>
+            <a:pPr algn="ctr"/>
+          </a:p>
+        </p:txBody>
+      </p:sp>
+      <p:sp>
+        <p:nvSpPr>
+          <p:cNvPr id="4" name="TextBox 3"/>
           <p:cNvSpPr txBox="1"/>
           <p:nvPr/>
         </p:nvSpPr>
         <p:spPr>
           <a:xfrm>
-            <a:off x="731520" y="1325880"/>
-            <a:ext cx="6400800" cy="4389120"/>
+            <a:off x="548640" y="1325880"/>
+            <a:ext cx="6492240" cy="5029200"/>
           </a:xfrm>
           <a:prstGeom prst="rect">
             <a:avLst/>
@@ -4615,7 +5027,7 @@
               <a:spcAft>
                 <a:spcPts val="1000"/>
               </a:spcAft>
-              <a:defRPr sz="2200">
+              <a:defRPr sz="1900">
                 <a:solidFill>
                   <a:srgbClr val="222222"/>
                 </a:solidFill>
@@ -4623,7 +5035,7 @@
               </a:defRPr>
             </a:pPr>
             <a:r>
-              <a:t>Step 1: Open a PR with intentional issues in Android/Kotlin files.</a:t>
+              <a:t>▸  Open a PR with intentional issues in MainActivity.kt.</a:t>
             </a:r>
           </a:p>
           <a:p>
@@ -4631,7 +5043,7 @@
               <a:spcAft>
                 <a:spcPts val="1000"/>
               </a:spcAft>
-              <a:defRPr sz="2200">
+              <a:defRPr sz="1900">
                 <a:solidFill>
                   <a:srgbClr val="222222"/>
                 </a:solidFill>
@@ -4639,7 +5051,7 @@
               </a:defRPr>
             </a:pPr>
             <a:r>
-              <a:t>Step 2: GitHub Action generates diff, runs tests, coverage, and lint.</a:t>
+              <a:t>▸  GitHub Action auto-triggers: diff → lint → coverage → Gemini call.</a:t>
             </a:r>
           </a:p>
           <a:p>
@@ -4647,7 +5059,7 @@
               <a:spcAft>
                 <a:spcPts val="1000"/>
               </a:spcAft>
-              <a:defRPr sz="2200">
+              <a:defRPr sz="1900">
                 <a:solidFill>
                   <a:srgbClr val="222222"/>
                 </a:solidFill>
@@ -4655,7 +5067,7 @@
               </a:defRPr>
             </a:pPr>
             <a:r>
-              <a:t>Step 3: Agent reviews only changed code and returns structured findings.</a:t>
+              <a:t>▸  Agent returns structured XML findings ordered by severity.</a:t>
             </a:r>
           </a:p>
           <a:p>
@@ -4663,7 +5075,7 @@
               <a:spcAft>
                 <a:spcPts val="1000"/>
               </a:spcAft>
-              <a:defRPr sz="2200">
+              <a:defRPr sz="1900">
                 <a:solidFill>
                   <a:srgbClr val="222222"/>
                 </a:solidFill>
@@ -4671,7 +5083,7 @@
               </a:defRPr>
             </a:pPr>
             <a:r>
-              <a:t>Step 4: Findings appear as line-level PR comments, not only as a generic summary.</a:t>
+              <a:t>▸  Each finding is posted as an inline comment on the exact changed line.</a:t>
             </a:r>
           </a:p>
           <a:p>
@@ -4679,7 +5091,7 @@
               <a:spcAft>
                 <a:spcPts val="1000"/>
               </a:spcAft>
-              <a:defRPr sz="2200">
+              <a:defRPr sz="1900">
                 <a:solidFill>
                   <a:srgbClr val="222222"/>
                 </a:solidFill>
@@ -4687,21 +5099,21 @@
               </a:defRPr>
             </a:pPr>
             <a:r>
-              <a:t>Step 5: Coverage alerts are added separately for repository / use-case logic when below threshold.</a:t>
-            </a:r>
-          </a:p>
-        </p:txBody>
-      </p:sp>
-      <p:sp>
-        <p:nvSpPr>
-          <p:cNvPr id="4" name="Rounded Rectangle 3"/>
+              <a:t>▸  Coverage alert posted separately when a business-logic file is below 75 %.</a:t>
+            </a:r>
+          </a:p>
+        </p:txBody>
+      </p:sp>
+      <p:sp>
+        <p:nvSpPr>
+          <p:cNvPr id="5" name="Rounded Rectangle 4"/>
           <p:cNvSpPr/>
           <p:nvPr/>
         </p:nvSpPr>
         <p:spPr>
           <a:xfrm>
-            <a:off x="7315200" y="1554480"/>
-            <a:ext cx="4297680" cy="1737360"/>
+            <a:off x="7315200" y="1371600"/>
+            <a:ext cx="4480560" cy="1874520"/>
           </a:xfrm>
           <a:prstGeom prst="roundRect">
             <a:avLst/>
@@ -4734,7 +5146,7 @@
           <a:lstStyle/>
           <a:p>
             <a:pPr algn="ctr">
-              <a:defRPr sz="1800" b="1">
+              <a:defRPr sz="1500" b="1">
                 <a:solidFill>
                   <a:srgbClr val="0E2C54"/>
                 </a:solidFill>
@@ -4742,7 +5154,15 @@
               </a:defRPr>
             </a:pPr>
             <a:r>
-              <a:t>Best demo line: 'The agent behaves like a staff engineer that reads context, reasons across specialties, and comments directly where the developer needs to act.'</a:t>
+              <a:t>Demo tip: 4 bugs planted —</a:t>
+            </a:r>
+            <a:br/>
+            <a:r>
+              <a:t>hardcoded API key · hardcoded log tag</a:t>
+            </a:r>
+            <a:br/>
+            <a:r>
+              <a:t>magic number 5000 · hardcoded welcome string</a:t>
             </a:r>
           </a:p>
         </p:txBody>
@@ -4781,8 +5201,8 @@
         </p:nvSpPr>
         <p:spPr>
           <a:xfrm>
-            <a:off x="502920" y="320040"/>
-            <a:ext cx="10972800" cy="731520"/>
+            <a:off x="502920" y="292608"/>
+            <a:ext cx="11155680" cy="685800"/>
           </a:xfrm>
           <a:prstGeom prst="rect">
             <a:avLst/>
@@ -4796,7 +5216,7 @@
           <a:lstStyle/>
           <a:p>
             <a:r>
-              <a:rPr sz="2800" b="1">
+              <a:rPr sz="2600" b="1">
                 <a:solidFill>
                   <a:srgbClr val="0E2C54"/>
                 </a:solidFill>
@@ -4809,14 +5229,57 @@
       </p:sp>
       <p:sp>
         <p:nvSpPr>
-          <p:cNvPr id="3" name="TextBox 2"/>
+          <p:cNvPr id="3" name="Rectangle 2"/>
+          <p:cNvSpPr/>
+          <p:nvPr/>
+        </p:nvSpPr>
+        <p:spPr>
+          <a:xfrm>
+            <a:off x="502920" y="950976"/>
+            <a:ext cx="11155680" cy="27432"/>
+          </a:xfrm>
+          <a:prstGeom prst="rect">
+            <a:avLst/>
+          </a:prstGeom>
+          <a:solidFill>
+            <a:srgbClr val="0081A7"/>
+          </a:solidFill>
+          <a:ln>
+            <a:noFill/>
+          </a:ln>
+        </p:spPr>
+        <p:style>
+          <a:lnRef idx="1">
+            <a:schemeClr val="accent1"/>
+          </a:lnRef>
+          <a:fillRef idx="3">
+            <a:schemeClr val="accent1"/>
+          </a:fillRef>
+          <a:effectRef idx="2">
+            <a:schemeClr val="accent1"/>
+          </a:effectRef>
+          <a:fontRef idx="minor">
+            <a:schemeClr val="lt1"/>
+          </a:fontRef>
+        </p:style>
+        <p:txBody>
+          <a:bodyPr rtlCol="0" anchor="ctr"/>
+          <a:lstStyle/>
+          <a:p>
+            <a:pPr algn="ctr"/>
+          </a:p>
+        </p:txBody>
+      </p:sp>
+      <p:sp>
+        <p:nvSpPr>
+          <p:cNvPr id="4" name="TextBox 3"/>
           <p:cNvSpPr txBox="1"/>
           <p:nvPr/>
         </p:nvSpPr>
         <p:spPr>
           <a:xfrm>
-            <a:off x="731520" y="1325880"/>
-            <a:ext cx="6400800" cy="4389120"/>
+            <a:off x="548640" y="1325880"/>
+            <a:ext cx="6492240" cy="5029200"/>
           </a:xfrm>
           <a:prstGeom prst="rect">
             <a:avLst/>
@@ -4833,7 +5296,7 @@
               <a:spcAft>
                 <a:spcPts val="1000"/>
               </a:spcAft>
-              <a:defRPr sz="2200">
+              <a:defRPr sz="1900">
                 <a:solidFill>
                   <a:srgbClr val="222222"/>
                 </a:solidFill>
@@ -4841,7 +5304,7 @@
               </a:defRPr>
             </a:pPr>
             <a:r>
-              <a:t>Faster feedback on every pull request</a:t>
+              <a:t>▸  Review feedback in ~2 minutes — not hours.</a:t>
             </a:r>
           </a:p>
           <a:p>
@@ -4849,7 +5312,7 @@
               <a:spcAft>
                 <a:spcPts val="1000"/>
               </a:spcAft>
-              <a:defRPr sz="2200">
+              <a:defRPr sz="1900">
                 <a:solidFill>
                   <a:srgbClr val="222222"/>
                 </a:solidFill>
@@ -4857,7 +5320,7 @@
               </a:defRPr>
             </a:pPr>
             <a:r>
-              <a:t>More consistent review quality across reviewers and repos</a:t>
+              <a:t>▸  Consistent quality: same bar on every PR, every repo.</a:t>
             </a:r>
           </a:p>
           <a:p>
@@ -4865,7 +5328,7 @@
               <a:spcAft>
                 <a:spcPts val="1000"/>
               </a:spcAft>
-              <a:defRPr sz="2200">
+              <a:defRPr sz="1900">
                 <a:solidFill>
                   <a:srgbClr val="222222"/>
                 </a:solidFill>
@@ -4873,7 +5336,7 @@
               </a:defRPr>
             </a:pPr>
             <a:r>
-              <a:t>Less reviewer time spent on repetitive checks</a:t>
+              <a:t>▸  Senior engineer time freed from repetitive checks.</a:t>
             </a:r>
           </a:p>
           <a:p>
@@ -4881,7 +5344,7 @@
               <a:spcAft>
                 <a:spcPts val="1000"/>
               </a:spcAft>
-              <a:defRPr sz="2200">
+              <a:defRPr sz="1900">
                 <a:solidFill>
                   <a:srgbClr val="222222"/>
                 </a:solidFill>
@@ -4889,37 +5352,21 @@
               </a:defRPr>
             </a:pPr>
             <a:r>
-              <a:t>Earlier detection of Android-specific quality and security issues</a:t>
-            </a:r>
-          </a:p>
-          <a:p>
-            <a:pPr>
-              <a:spcAft>
-                <a:spcPts val="1000"/>
-              </a:spcAft>
-              <a:defRPr sz="2200">
-                <a:solidFill>
-                  <a:srgbClr val="222222"/>
-                </a:solidFill>
-                <a:latin typeface="Aptos"/>
-              </a:defRPr>
-            </a:pPr>
-            <a:r>
-              <a:t>Reusable review policy encoded as version-controlled agent prompts</a:t>
-            </a:r>
-          </a:p>
-        </p:txBody>
-      </p:sp>
-      <p:sp>
-        <p:nvSpPr>
-          <p:cNvPr id="4" name="Rounded Rectangle 3"/>
+              <a:t>▸  Reusable policy: rules are version-controlled agent prompts.</a:t>
+            </a:r>
+          </a:p>
+        </p:txBody>
+      </p:sp>
+      <p:sp>
+        <p:nvSpPr>
+          <p:cNvPr id="5" name="Rounded Rectangle 4"/>
           <p:cNvSpPr/>
           <p:nvPr/>
         </p:nvSpPr>
         <p:spPr>
           <a:xfrm>
-            <a:off x="7223760" y="3657600"/>
-            <a:ext cx="4389120" cy="566928"/>
+            <a:off x="7223760" y="3474720"/>
+            <a:ext cx="4572000" cy="621792"/>
           </a:xfrm>
           <a:prstGeom prst="roundRect">
             <a:avLst/>
@@ -4952,7 +5399,7 @@
           <a:lstStyle/>
           <a:p>
             <a:pPr algn="ctr">
-              <a:defRPr sz="1400">
+              <a:defRPr sz="1300">
                 <a:solidFill>
                   <a:srgbClr val="222222"/>
                 </a:solidFill>
@@ -4960,21 +5407,21 @@
               </a:defRPr>
             </a:pPr>
             <a:r>
-              <a:t>Cycle time: Reduce back-and-forth by shifting common issues earlier</a:t>
-            </a:r>
-          </a:p>
-        </p:txBody>
-      </p:sp>
-      <p:sp>
-        <p:nvSpPr>
-          <p:cNvPr id="5" name="Rounded Rectangle 4"/>
+              <a:t>  Cycle time:  Earlier feedback → fewer back-and-forth rounds</a:t>
+            </a:r>
+          </a:p>
+        </p:txBody>
+      </p:sp>
+      <p:sp>
+        <p:nvSpPr>
+          <p:cNvPr id="6" name="Rounded Rectangle 5"/>
           <p:cNvSpPr/>
           <p:nvPr/>
         </p:nvSpPr>
         <p:spPr>
           <a:xfrm>
-            <a:off x="7223760" y="4343400"/>
-            <a:ext cx="4389120" cy="566928"/>
+            <a:off x="7223760" y="4224528"/>
+            <a:ext cx="4572000" cy="621792"/>
           </a:xfrm>
           <a:prstGeom prst="roundRect">
             <a:avLst/>
@@ -5007,7 +5454,7 @@
           <a:lstStyle/>
           <a:p>
             <a:pPr algn="ctr">
-              <a:defRPr sz="1400">
+              <a:defRPr sz="1300">
                 <a:solidFill>
                   <a:srgbClr val="222222"/>
                 </a:solidFill>
@@ -5015,21 +5462,21 @@
               </a:defRPr>
             </a:pPr>
             <a:r>
-              <a:t>Quality signal: Lint + coverage + structured review in one pass</a:t>
-            </a:r>
-          </a:p>
-        </p:txBody>
-      </p:sp>
-      <p:sp>
-        <p:nvSpPr>
-          <p:cNvPr id="6" name="Rounded Rectangle 5"/>
+              <a:t>  Quality gate:  Lint + coverage + structured review in one automated pass</a:t>
+            </a:r>
+          </a:p>
+        </p:txBody>
+      </p:sp>
+      <p:sp>
+        <p:nvSpPr>
+          <p:cNvPr id="7" name="Rounded Rectangle 6"/>
           <p:cNvSpPr/>
           <p:nvPr/>
         </p:nvSpPr>
         <p:spPr>
           <a:xfrm>
-            <a:off x="7223760" y="5029200"/>
-            <a:ext cx="4389120" cy="566928"/>
+            <a:off x="7223760" y="4974336"/>
+            <a:ext cx="4572000" cy="621792"/>
           </a:xfrm>
           <a:prstGeom prst="roundRect">
             <a:avLst/>
@@ -5062,7 +5509,7 @@
           <a:lstStyle/>
           <a:p>
             <a:pPr algn="ctr">
-              <a:defRPr sz="1400">
+              <a:defRPr sz="1300">
                 <a:solidFill>
                   <a:srgbClr val="222222"/>
                 </a:solidFill>
@@ -5070,7 +5517,7 @@
               </a:defRPr>
             </a:pPr>
             <a:r>
-              <a:t>Scalability: Apply same pattern across multiple Android projects</a:t>
+              <a:t>  Scale:  Copy 3 files → works on any Android project</a:t>
             </a:r>
           </a:p>
         </p:txBody>
@@ -5109,8 +5556,8 @@
         </p:nvSpPr>
         <p:spPr>
           <a:xfrm>
-            <a:off x="502920" y="320040"/>
-            <a:ext cx="10972800" cy="731520"/>
+            <a:off x="502920" y="292608"/>
+            <a:ext cx="11155680" cy="685800"/>
           </a:xfrm>
           <a:prstGeom prst="rect">
             <a:avLst/>
@@ -5124,27 +5571,70 @@
           <a:lstStyle/>
           <a:p>
             <a:r>
-              <a:rPr sz="2800" b="1">
+              <a:rPr sz="2600" b="1">
                 <a:solidFill>
                   <a:srgbClr val="0E2C54"/>
                 </a:solidFill>
                 <a:latin typeface="Aptos"/>
               </a:rPr>
-              <a:t>Rollout Recommendation</a:t>
-            </a:r>
-          </a:p>
-        </p:txBody>
-      </p:sp>
-      <p:sp>
-        <p:nvSpPr>
-          <p:cNvPr id="3" name="TextBox 2"/>
+              <a:t>How to Add This to Any Android Project</a:t>
+            </a:r>
+          </a:p>
+        </p:txBody>
+      </p:sp>
+      <p:sp>
+        <p:nvSpPr>
+          <p:cNvPr id="3" name="Rectangle 2"/>
+          <p:cNvSpPr/>
+          <p:nvPr/>
+        </p:nvSpPr>
+        <p:spPr>
+          <a:xfrm>
+            <a:off x="502920" y="950976"/>
+            <a:ext cx="11155680" cy="27432"/>
+          </a:xfrm>
+          <a:prstGeom prst="rect">
+            <a:avLst/>
+          </a:prstGeom>
+          <a:solidFill>
+            <a:srgbClr val="0081A7"/>
+          </a:solidFill>
+          <a:ln>
+            <a:noFill/>
+          </a:ln>
+        </p:spPr>
+        <p:style>
+          <a:lnRef idx="1">
+            <a:schemeClr val="accent1"/>
+          </a:lnRef>
+          <a:fillRef idx="3">
+            <a:schemeClr val="accent1"/>
+          </a:fillRef>
+          <a:effectRef idx="2">
+            <a:schemeClr val="accent1"/>
+          </a:effectRef>
+          <a:fontRef idx="minor">
+            <a:schemeClr val="lt1"/>
+          </a:fontRef>
+        </p:style>
+        <p:txBody>
+          <a:bodyPr rtlCol="0" anchor="ctr"/>
+          <a:lstStyle/>
+          <a:p>
+            <a:pPr algn="ctr"/>
+          </a:p>
+        </p:txBody>
+      </p:sp>
+      <p:sp>
+        <p:nvSpPr>
+          <p:cNvPr id="4" name="TextBox 3"/>
           <p:cNvSpPr txBox="1"/>
           <p:nvPr/>
         </p:nvSpPr>
         <p:spPr>
           <a:xfrm>
-            <a:off x="731520" y="1325880"/>
-            <a:ext cx="6400800" cy="4389120"/>
+            <a:off x="548640" y="1325880"/>
+            <a:ext cx="6492240" cy="5029200"/>
           </a:xfrm>
           <a:prstGeom prst="rect">
             <a:avLst/>
@@ -5161,7 +5651,7 @@
               <a:spcAft>
                 <a:spcPts val="1000"/>
               </a:spcAft>
-              <a:defRPr sz="2200">
+              <a:defRPr sz="1900">
                 <a:solidFill>
                   <a:srgbClr val="222222"/>
                 </a:solidFill>
@@ -5169,7 +5659,7 @@
               </a:defRPr>
             </a:pPr>
             <a:r>
-              <a:t>Start in review-only mode on one Android repository.</a:t>
+              <a:t>▸  Copy .github/workflows/ai-pr-reviewer.yml to your repo.</a:t>
             </a:r>
           </a:p>
           <a:p>
@@ -5177,7 +5667,7 @@
               <a:spcAft>
                 <a:spcPts val="1000"/>
               </a:spcAft>
-              <a:defRPr sz="2200">
+              <a:defRPr sz="1900">
                 <a:solidFill>
                   <a:srgbClr val="222222"/>
                 </a:solidFill>
@@ -5185,7 +5675,7 @@
               </a:defRPr>
             </a:pPr>
             <a:r>
-              <a:t>Track false positives and tune the prompt files for 1–2 sprints.</a:t>
+              <a:t>▸  Copy .github/scripts/run_agent.py and master-reviewer-agent.md.</a:t>
             </a:r>
           </a:p>
           <a:p>
@@ -5193,7 +5683,7 @@
               <a:spcAft>
                 <a:spcPts val="1000"/>
               </a:spcAft>
-              <a:defRPr sz="2200">
+              <a:defRPr sz="1900">
                 <a:solidFill>
                   <a:srgbClr val="222222"/>
                 </a:solidFill>
@@ -5201,7 +5691,7 @@
               </a:defRPr>
             </a:pPr>
             <a:r>
-              <a:t>Keep humans in the loop; use the agent to accelerate, not replace, engineering judgment.</a:t>
+              <a:t>▸  Add LLM_API_KEY to GitHub → Settings → Secrets.</a:t>
             </a:r>
           </a:p>
           <a:p>
@@ -5209,7 +5699,7 @@
               <a:spcAft>
                 <a:spcPts val="1000"/>
               </a:spcAft>
-              <a:defRPr sz="2200">
+              <a:defRPr sz="1900">
                 <a:solidFill>
                   <a:srgbClr val="222222"/>
                 </a:solidFill>
@@ -5217,7 +5707,78 @@
               </a:defRPr>
             </a:pPr>
             <a:r>
-              <a:t>Then templatize the workflow and prompt set for additional mobile projects.</a:t>
+              <a:t>▸  Optionally edit the .md prompt files to match your project's rules.</a:t>
+            </a:r>
+          </a:p>
+          <a:p>
+            <a:pPr>
+              <a:spcAft>
+                <a:spcPts val="1000"/>
+              </a:spcAft>
+              <a:defRPr sz="1900">
+                <a:solidFill>
+                  <a:srgbClr val="222222"/>
+                </a:solidFill>
+                <a:latin typeface="Aptos"/>
+              </a:defRPr>
+            </a:pPr>
+            <a:r>
+              <a:t>▸  Open a PR — the agent runs automatically.</a:t>
+            </a:r>
+          </a:p>
+        </p:txBody>
+      </p:sp>
+      <p:sp>
+        <p:nvSpPr>
+          <p:cNvPr id="5" name="Rounded Rectangle 4"/>
+          <p:cNvSpPr/>
+          <p:nvPr/>
+        </p:nvSpPr>
+        <p:spPr>
+          <a:xfrm>
+            <a:off x="7315200" y="1371600"/>
+            <a:ext cx="4480560" cy="914400"/>
+          </a:xfrm>
+          <a:prstGeom prst="roundRect">
+            <a:avLst/>
+          </a:prstGeom>
+          <a:solidFill>
+            <a:srgbClr val="E5EEF6"/>
+          </a:solidFill>
+          <a:ln>
+            <a:solidFill>
+              <a:srgbClr val="0081A7"/>
+            </a:solidFill>
+          </a:ln>
+        </p:spPr>
+        <p:style>
+          <a:lnRef idx="1">
+            <a:schemeClr val="accent1"/>
+          </a:lnRef>
+          <a:fillRef idx="3">
+            <a:schemeClr val="accent1"/>
+          </a:fillRef>
+          <a:effectRef idx="2">
+            <a:schemeClr val="accent1"/>
+          </a:effectRef>
+          <a:fontRef idx="minor">
+            <a:schemeClr val="lt1"/>
+          </a:fontRef>
+        </p:style>
+        <p:txBody>
+          <a:bodyPr rtlCol="0" anchor="ctr" wrap="square"/>
+          <a:lstStyle/>
+          <a:p>
+            <a:pPr algn="ctr">
+              <a:defRPr sz="1500" b="1">
+                <a:solidFill>
+                  <a:srgbClr val="0E2C54"/>
+                </a:solidFill>
+                <a:latin typeface="Aptos"/>
+              </a:defRPr>
+            </a:pPr>
+            <a:r>
+              <a:t>Total setup time: ~15 minutes</a:t>
             </a:r>
           </a:p>
         </p:txBody>

</xml_diff>